<commit_message>
Support PowerPoint "Last Slide Viewed" back links
A shape with Hyperlink to: Last Slide Viewed
(ppaction://hlinkshowjump?jump=lastslideviewed) now returns to whichever
slide the visitor came from, e.g. a shared Terms and Conditions slide.

Previously the parser matched it as "lastslide" and jumped to the final
slide of the deck.

- Parser: SlideLink.back, new Deck.backLinks (BackLinkDef); back links are
  never buttons, Home links or nav links
- Kiosk: per-visit slide history; back pops it (slide_nav), or returns
  Home when the visit started on that slide; cleared on every return home
- A back link counts as a way out for no_home_link and the fallback Home
  button, but does not make slides reachable
- Setup preview outlines back links and follows the same history
- multi-slide.pptx fixture gains a Terms slide; SPEC and PLAN updated

Co-Authored-By: Claude Opus 5.5 <noreply@anthropic.com>
Claude-Session: https://claude.ai/code/session_018wpHV9kj3iP84uJKHE6EUu
</commit_message>
<xml_diff>
--- a/tests/fixtures/multi-slide.pptx
+++ b/tests/fixtures/multi-slide.pptx
@@ -9,9 +9,10 @@
     <p:sldId id="257" r:id="rId3"/>
     <p:sldId id="258" r:id="rId4"/>
     <p:sldId id="259" r:id="rId5"/>
+    <p:sldId id="260" r:id="rId6"/>
   </p:sldIdLst>
   <p:notesMasterIdLst>
-    <p:notesMasterId r:id="rId6"/>
+    <p:notesMasterId r:id="rId7"/>
   </p:notesMasterIdLst>
   <p:sldSz cx="12191695" cy="6858000"/>
   <p:notesSz cx="6858000" cy="12191695"/>
@@ -793,6 +794,94 @@
             <a:fld id="{F7021451-1387-4CA6-816F-3879F97B5CBC}" type="slidenum">
               <a:rPr lang="en-US"/>
               <a:t>4</a:t>
+            </a:fld>
+            <a:endParaRPr lang="en-US"/>
+          </a:p>
+        </p:txBody>
+      </p:sp>
+    </p:spTree>
+    <p:extLst>
+      <p:ext uri="{BB962C8B-B14F-4D97-AF65-F5344CB8AC3E}">
+        <p14:creationId xmlns:p14="http://schemas.microsoft.com/office/powerpoint/2010/main" val="1024086991"/>
+      </p:ext>
+    </p:extLst>
+  </p:cSld>
+  <p:clrMapOvr>
+    <a:masterClrMapping/>
+  </p:clrMapOvr>
+</p:notes>
+</file>
+
+<file path=ppt/notesSlides/notesSlide5.xml><?xml version="1.0" encoding="utf-8"?>
+<p:notes xmlns:a="http://schemas.openxmlformats.org/drawingml/2006/main" xmlns:r="http://schemas.openxmlformats.org/officeDocument/2006/relationships" xmlns:p="http://schemas.openxmlformats.org/presentationml/2006/main">
+  <p:cSld>
+    <p:spTree>
+      <p:nvGrpSpPr>
+        <p:cNvPr id="1" name=""/>
+        <p:cNvGrpSpPr/>
+        <p:nvPr/>
+      </p:nvGrpSpPr>
+      <p:grpSpPr>
+        <a:xfrm>
+          <a:off x="0" y="0"/>
+          <a:ext cx="0" cy="0"/>
+          <a:chOff x="0" y="0"/>
+          <a:chExt cx="0" cy="0"/>
+        </a:xfrm>
+      </p:grpSpPr>
+      <p:sp>
+        <p:nvSpPr>
+          <p:cNvPr id="2" name="Slide Image Placeholder 1"/>
+          <p:cNvSpPr>
+            <a:spLocks noGrp="1" noRot="1" noChangeAspect="1"/>
+          </p:cNvSpPr>
+          <p:nvPr>
+            <p:ph type="sldImg"/>
+          </p:nvPr>
+        </p:nvSpPr>
+        <p:spPr/>
+      </p:sp>
+      <p:sp>
+        <p:nvSpPr>
+          <p:cNvPr id="3" name="Notes Placeholder 2"/>
+          <p:cNvSpPr>
+            <a:spLocks noGrp="1"/>
+          </p:cNvSpPr>
+          <p:nvPr>
+            <p:ph type="body" idx="1"/>
+          </p:nvPr>
+        </p:nvSpPr>
+        <p:spPr/>
+        <p:txBody>
+          <a:bodyPr/>
+          <a:lstStyle/>
+          <a:p>
+            <a:r>
+              <a:rPr lang="en-US" dirty="0"/>
+              <a:t/>
+            </a:r>
+            <a:endParaRPr lang="en-US" dirty="0"/>
+          </a:p>
+        </p:txBody>
+      </p:sp>
+      <p:sp>
+        <p:nvSpPr>
+          <p:cNvPr id="4" name="Slide Number Placeholder 3"/>
+          <p:cNvSpPr>
+            <a:spLocks noGrp="1"/>
+          </p:cNvSpPr>
+          <p:nvPr>
+            <p:ph type="sldNum" sz="quarter" idx="10"/>
+          </p:nvPr>
+        </p:nvSpPr>
+        <p:spPr/>
+        <p:txBody>
+          <a:bodyPr/>
+          <a:lstStyle/>
+          <a:p>
+            <a:fld id="{F7021451-1387-4CA6-816F-3879F97B5CBC}" type="slidenum">
+              <a:rPr lang="en-US"/>
+              <a:t>5</a:t>
             </a:fld>
             <a:endParaRPr lang="en-US"/>
           </a:p>
@@ -1432,6 +1521,51 @@
           </a:p>
         </p:txBody>
       </p:sp>
+      <p:sp>
+        <p:nvSpPr>
+          <p:cNvPr id="5" name="BTN_Terms">
+            <a:hlinkClick r:id="rId3" tooltip="" action="ppaction://hlinksldjump"/>
+          </p:cNvPr>
+          <p:cNvSpPr/>
+          <p:nvPr/>
+        </p:nvSpPr>
+        <p:spPr>
+          <a:xfrm>
+            <a:off x="4206240" y="5943600"/>
+            <a:ext cx="1645920" cy="548640"/>
+          </a:xfrm>
+          <a:prstGeom prst="roundRect">
+            <a:avLst>
+              <a:gd name="adj" fmla="val 25000"/>
+            </a:avLst>
+          </a:prstGeom>
+          <a:solidFill>
+            <a:srgbClr val="8A5D2E"/>
+          </a:solidFill>
+          <a:ln/>
+        </p:spPr>
+        <p:txBody>
+          <a:bodyPr wrap="square" rtlCol="0" anchor="ctr"/>
+          <a:lstStyle/>
+          <a:p>
+            <a:pPr algn="ctr" indent="0" marL="0">
+              <a:buNone/>
+            </a:pPr>
+            <a:r>
+              <a:rPr lang="en-US" sz="1400" b="1" dirty="0">
+                <a:solidFill>
+                  <a:srgbClr val="FFFFFF"/>
+                </a:solidFill>
+                <a:latin typeface="Helvetica Neue" pitchFamily="34" charset="0"/>
+                <a:ea typeface="Helvetica Neue" pitchFamily="34" charset="-122"/>
+                <a:cs typeface="Helvetica Neue" pitchFamily="34" charset="-120"/>
+              </a:rPr>
+              <a:t>Terms</a:t>
+            </a:r>
+            <a:endParaRPr lang="en-US" sz="1400" dirty="0"/>
+          </a:p>
+        </p:txBody>
+      </p:sp>
     </p:spTree>
   </p:cSld>
   <p:clrMapOvr>
@@ -1593,6 +1727,51 @@
           </a:p>
         </p:txBody>
       </p:sp>
+      <p:sp>
+        <p:nvSpPr>
+          <p:cNvPr id="5" name="BTN_Terms">
+            <a:hlinkClick r:id="rId2" tooltip="" action="ppaction://hlinksldjump"/>
+          </p:cNvPr>
+          <p:cNvSpPr/>
+          <p:nvPr/>
+        </p:nvSpPr>
+        <p:spPr>
+          <a:xfrm>
+            <a:off x="4206240" y="5943600"/>
+            <a:ext cx="1645920" cy="548640"/>
+          </a:xfrm>
+          <a:prstGeom prst="roundRect">
+            <a:avLst>
+              <a:gd name="adj" fmla="val 25000"/>
+            </a:avLst>
+          </a:prstGeom>
+          <a:solidFill>
+            <a:srgbClr val="8A5D2E"/>
+          </a:solidFill>
+          <a:ln/>
+        </p:spPr>
+        <p:txBody>
+          <a:bodyPr wrap="square" rtlCol="0" anchor="ctr"/>
+          <a:lstStyle/>
+          <a:p>
+            <a:pPr algn="ctr" indent="0" marL="0">
+              <a:buNone/>
+            </a:pPr>
+            <a:r>
+              <a:rPr lang="en-US" sz="1400" b="1" dirty="0">
+                <a:solidFill>
+                  <a:srgbClr val="FFFFFF"/>
+                </a:solidFill>
+                <a:latin typeface="Helvetica Neue" pitchFamily="34" charset="0"/>
+                <a:ea typeface="Helvetica Neue" pitchFamily="34" charset="-122"/>
+                <a:cs typeface="Helvetica Neue" pitchFamily="34" charset="-120"/>
+              </a:rPr>
+              <a:t>Terms</a:t>
+            </a:r>
+            <a:endParaRPr lang="en-US" sz="1400" dirty="0"/>
+          </a:p>
+        </p:txBody>
+      </p:sp>
     </p:spTree>
   </p:cSld>
   <p:clrMapOvr>
@@ -1749,6 +1928,122 @@
                 <a:cs typeface="Helvetica Neue" pitchFamily="34" charset="-120"/>
               </a:rPr>
               <a:t>Home</a:t>
+            </a:r>
+            <a:endParaRPr lang="en-US" sz="1400" dirty="0"/>
+          </a:p>
+        </p:txBody>
+      </p:sp>
+    </p:spTree>
+  </p:cSld>
+  <p:clrMapOvr>
+    <a:masterClrMapping/>
+  </p:clrMapOvr>
+</p:sld>
+</file>
+
+<file path=ppt/slides/slide5.xml><?xml version="1.0" encoding="utf-8"?>
+<p:sld xmlns:a="http://schemas.openxmlformats.org/drawingml/2006/main" xmlns:r="http://schemas.openxmlformats.org/officeDocument/2006/relationships" xmlns:p="http://schemas.openxmlformats.org/presentationml/2006/main">
+  <p:cSld name="Slide 5">
+    <p:bg>
+      <p:bgPr>
+        <a:solidFill>
+          <a:srgbClr val="F5F3EE"/>
+        </a:solidFill>
+      </p:bgPr>
+    </p:bg>
+    <p:spTree>
+      <p:nvGrpSpPr>
+        <p:cNvPr id="1" name=""/>
+        <p:cNvGrpSpPr/>
+        <p:nvPr/>
+      </p:nvGrpSpPr>
+      <p:grpSpPr>
+        <a:xfrm>
+          <a:off x="0" y="0"/>
+          <a:ext cx="0" cy="0"/>
+          <a:chOff x="0" y="0"/>
+          <a:chExt cx="0" cy="0"/>
+        </a:xfrm>
+      </p:grpSpPr>
+      <p:sp>
+        <p:nvSpPr>
+          <p:cNvPr id="2" name="Text 0"/>
+          <p:cNvSpPr/>
+          <p:nvPr/>
+        </p:nvSpPr>
+        <p:spPr>
+          <a:xfrm>
+            <a:off x="548640" y="457200"/>
+            <a:ext cx="10972800" cy="914400"/>
+          </a:xfrm>
+          <a:prstGeom prst="rect">
+            <a:avLst/>
+          </a:prstGeom>
+          <a:noFill/>
+          <a:ln/>
+        </p:spPr>
+        <p:txBody>
+          <a:bodyPr wrap="square" rtlCol="0" anchor="ctr"/>
+          <a:lstStyle/>
+          <a:p>
+            <a:pPr indent="0" marL="0">
+              <a:buNone/>
+            </a:pPr>
+            <a:r>
+              <a:rPr lang="en-US" sz="2800" b="1" dirty="0">
+                <a:solidFill>
+                  <a:srgbClr val="1B2A4A"/>
+                </a:solidFill>
+                <a:latin typeface="Helvetica Neue" pitchFamily="34" charset="0"/>
+                <a:ea typeface="Helvetica Neue" pitchFamily="34" charset="-122"/>
+                <a:cs typeface="Helvetica Neue" pitchFamily="34" charset="-120"/>
+              </a:rPr>
+              <a:t>Terms and conditions</a:t>
+            </a:r>
+            <a:endParaRPr lang="en-US" sz="2800" dirty="0"/>
+          </a:p>
+        </p:txBody>
+      </p:sp>
+      <p:sp>
+        <p:nvSpPr>
+          <p:cNvPr id="3" name="BTN_Back">
+            <a:hlinkClick xmlns:r="http://schemas.openxmlformats.org/officeDocument/2006/relationships" action="ppaction://hlinkshowjump?jump=lastslideviewed"/>
+          </p:cNvPr>
+          <p:cNvSpPr/>
+          <p:nvPr/>
+        </p:nvSpPr>
+        <p:spPr>
+          <a:xfrm>
+            <a:off x="548640" y="5943600"/>
+            <a:ext cx="1645920" cy="548640"/>
+          </a:xfrm>
+          <a:prstGeom prst="roundRect">
+            <a:avLst>
+              <a:gd name="adj" fmla="val 25000"/>
+            </a:avLst>
+          </a:prstGeom>
+          <a:solidFill>
+            <a:srgbClr val="1B2A4A"/>
+          </a:solidFill>
+          <a:ln/>
+        </p:spPr>
+        <p:txBody>
+          <a:bodyPr wrap="square" rtlCol="0" anchor="ctr"/>
+          <a:lstStyle/>
+          <a:p>
+            <a:pPr algn="ctr" indent="0" marL="0">
+              <a:buNone/>
+            </a:pPr>
+            <a:r>
+              <a:rPr lang="en-US" sz="1400" b="1" dirty="0">
+                <a:solidFill>
+                  <a:srgbClr val="FFFFFF"/>
+                </a:solidFill>
+                <a:latin typeface="Helvetica Neue" pitchFamily="34" charset="0"/>
+                <a:ea typeface="Helvetica Neue" pitchFamily="34" charset="-122"/>
+                <a:cs typeface="Helvetica Neue" pitchFamily="34" charset="-120"/>
+              </a:rPr>
+              <a:t>Back</a:t>
             </a:r>
             <a:endParaRPr lang="en-US" sz="1400" dirty="0"/>
           </a:p>

</xml_diff>